<commit_message>
Update the figure pipeline with final bliss threshold and statistics
</commit_message>
<xml_diff>
--- a/figure_pipeline/fig1_feats_data/assemble_fig1/assemble_fig1.pptx
+++ b/figure_pipeline/fig1_feats_data/assemble_fig1/assemble_fig1.pptx
@@ -243,7 +243,7 @@
           <a:p>
             <a:fld id="{3C3A1913-85D1-4C4E-AA02-085C6FE2A8B8}" type="datetimeFigureOut">
               <a:rPr lang="en-US" smtClean="0"/>
-              <a:t>1/16/2026</a:t>
+              <a:t>4/17/2026</a:t>
             </a:fld>
             <a:endParaRPr lang="en-US"/>
           </a:p>
@@ -413,7 +413,7 @@
           <a:p>
             <a:fld id="{3C3A1913-85D1-4C4E-AA02-085C6FE2A8B8}" type="datetimeFigureOut">
               <a:rPr lang="en-US" smtClean="0"/>
-              <a:t>1/16/2026</a:t>
+              <a:t>4/17/2026</a:t>
             </a:fld>
             <a:endParaRPr lang="en-US"/>
           </a:p>
@@ -593,7 +593,7 @@
           <a:p>
             <a:fld id="{3C3A1913-85D1-4C4E-AA02-085C6FE2A8B8}" type="datetimeFigureOut">
               <a:rPr lang="en-US" smtClean="0"/>
-              <a:t>1/16/2026</a:t>
+              <a:t>4/17/2026</a:t>
             </a:fld>
             <a:endParaRPr lang="en-US"/>
           </a:p>
@@ -763,7 +763,7 @@
           <a:p>
             <a:fld id="{3C3A1913-85D1-4C4E-AA02-085C6FE2A8B8}" type="datetimeFigureOut">
               <a:rPr lang="en-US" smtClean="0"/>
-              <a:t>1/16/2026</a:t>
+              <a:t>4/17/2026</a:t>
             </a:fld>
             <a:endParaRPr lang="en-US"/>
           </a:p>
@@ -1007,7 +1007,7 @@
           <a:p>
             <a:fld id="{3C3A1913-85D1-4C4E-AA02-085C6FE2A8B8}" type="datetimeFigureOut">
               <a:rPr lang="en-US" smtClean="0"/>
-              <a:t>1/16/2026</a:t>
+              <a:t>4/17/2026</a:t>
             </a:fld>
             <a:endParaRPr lang="en-US"/>
           </a:p>
@@ -1239,7 +1239,7 @@
           <a:p>
             <a:fld id="{3C3A1913-85D1-4C4E-AA02-085C6FE2A8B8}" type="datetimeFigureOut">
               <a:rPr lang="en-US" smtClean="0"/>
-              <a:t>1/16/2026</a:t>
+              <a:t>4/17/2026</a:t>
             </a:fld>
             <a:endParaRPr lang="en-US"/>
           </a:p>
@@ -1606,7 +1606,7 @@
           <a:p>
             <a:fld id="{3C3A1913-85D1-4C4E-AA02-085C6FE2A8B8}" type="datetimeFigureOut">
               <a:rPr lang="en-US" smtClean="0"/>
-              <a:t>1/16/2026</a:t>
+              <a:t>4/17/2026</a:t>
             </a:fld>
             <a:endParaRPr lang="en-US"/>
           </a:p>
@@ -1724,7 +1724,7 @@
           <a:p>
             <a:fld id="{3C3A1913-85D1-4C4E-AA02-085C6FE2A8B8}" type="datetimeFigureOut">
               <a:rPr lang="en-US" smtClean="0"/>
-              <a:t>1/16/2026</a:t>
+              <a:t>4/17/2026</a:t>
             </a:fld>
             <a:endParaRPr lang="en-US"/>
           </a:p>
@@ -1819,7 +1819,7 @@
           <a:p>
             <a:fld id="{3C3A1913-85D1-4C4E-AA02-085C6FE2A8B8}" type="datetimeFigureOut">
               <a:rPr lang="en-US" smtClean="0"/>
-              <a:t>1/16/2026</a:t>
+              <a:t>4/17/2026</a:t>
             </a:fld>
             <a:endParaRPr lang="en-US"/>
           </a:p>
@@ -2096,7 +2096,7 @@
           <a:p>
             <a:fld id="{3C3A1913-85D1-4C4E-AA02-085C6FE2A8B8}" type="datetimeFigureOut">
               <a:rPr lang="en-US" smtClean="0"/>
-              <a:t>1/16/2026</a:t>
+              <a:t>4/17/2026</a:t>
             </a:fld>
             <a:endParaRPr lang="en-US"/>
           </a:p>
@@ -2353,7 +2353,7 @@
           <a:p>
             <a:fld id="{3C3A1913-85D1-4C4E-AA02-085C6FE2A8B8}" type="datetimeFigureOut">
               <a:rPr lang="en-US" smtClean="0"/>
-              <a:t>1/16/2026</a:t>
+              <a:t>4/17/2026</a:t>
             </a:fld>
             <a:endParaRPr lang="en-US"/>
           </a:p>
@@ -2566,7 +2566,7 @@
           <a:p>
             <a:fld id="{3C3A1913-85D1-4C4E-AA02-085C6FE2A8B8}" type="datetimeFigureOut">
               <a:rPr lang="en-US" smtClean="0"/>
-              <a:t>1/16/2026</a:t>
+              <a:t>4/17/2026</a:t>
             </a:fld>
             <a:endParaRPr lang="en-US"/>
           </a:p>
@@ -2973,10 +2973,10 @@
       </p:grpSpPr>
       <p:pic>
         <p:nvPicPr>
-          <p:cNvPr id="4" name="Picture 3">
+          <p:cNvPr id="14" name="Picture 13">
             <a:extLst>
               <a:ext uri="{FF2B5EF4-FFF2-40B4-BE49-F238E27FC236}">
-                <a16:creationId xmlns:a16="http://schemas.microsoft.com/office/drawing/2014/main" id="{E669E2FE-DACD-1AB3-F823-F8FC24975F16}"/>
+                <a16:creationId xmlns:a16="http://schemas.microsoft.com/office/drawing/2014/main" id="{94D35E4B-42D9-160F-C38B-96AACF4EDDB8}"/>
               </a:ext>
             </a:extLst>
           </p:cNvPr>
@@ -2993,15 +2993,15 @@
               </a:ext>
             </a:extLst>
           </a:blip>
-          <a:srcRect l="2200" t="1956" r="49000" b="24756"/>
+          <a:srcRect l="851" t="2223" r="49575" b="23738"/>
           <a:stretch>
             <a:fillRect/>
           </a:stretch>
         </p:blipFill>
         <p:spPr>
           <a:xfrm>
-            <a:off x="25104" y="1878988"/>
-            <a:ext cx="4507992" cy="3808303"/>
+            <a:off x="4610898" y="2007061"/>
+            <a:ext cx="4533102" cy="3808303"/>
           </a:xfrm>
           <a:prstGeom prst="rect">
             <a:avLst/>
@@ -3010,10 +3010,10 @@
       </p:pic>
       <p:pic>
         <p:nvPicPr>
-          <p:cNvPr id="12" name="Picture 11">
+          <p:cNvPr id="3" name="Picture 2">
             <a:extLst>
               <a:ext uri="{FF2B5EF4-FFF2-40B4-BE49-F238E27FC236}">
-                <a16:creationId xmlns:a16="http://schemas.microsoft.com/office/drawing/2014/main" id="{E372F2FA-47C0-2723-326E-692BE1871E44}"/>
+                <a16:creationId xmlns:a16="http://schemas.microsoft.com/office/drawing/2014/main" id="{3DA46CCC-C79F-A534-645C-2D407E7C08BA}"/>
               </a:ext>
             </a:extLst>
           </p:cNvPr>
@@ -3030,15 +3030,15 @@
               </a:ext>
             </a:extLst>
           </a:blip>
-          <a:srcRect l="1945" t="3088" b="63703"/>
+          <a:srcRect l="2801" t="2895" b="60269"/>
           <a:stretch>
             <a:fillRect/>
           </a:stretch>
         </p:blipFill>
         <p:spPr>
           <a:xfrm>
-            <a:off x="-1" y="0"/>
-            <a:ext cx="9066195" cy="1727200"/>
+            <a:off x="7402" y="-1"/>
+            <a:ext cx="9136598" cy="1947744"/>
           </a:xfrm>
           <a:prstGeom prst="rect">
             <a:avLst/>
@@ -3047,10 +3047,10 @@
       </p:pic>
       <p:pic>
         <p:nvPicPr>
-          <p:cNvPr id="14" name="Picture 13">
+          <p:cNvPr id="5" name="Picture 4">
             <a:extLst>
               <a:ext uri="{FF2B5EF4-FFF2-40B4-BE49-F238E27FC236}">
-                <a16:creationId xmlns:a16="http://schemas.microsoft.com/office/drawing/2014/main" id="{94D35E4B-42D9-160F-C38B-96AACF4EDDB8}"/>
+                <a16:creationId xmlns:a16="http://schemas.microsoft.com/office/drawing/2014/main" id="{41CE8426-B325-E40E-A5AF-2EDCF40620AF}"/>
               </a:ext>
             </a:extLst>
           </p:cNvPr>
@@ -3067,15 +3067,15 @@
               </a:ext>
             </a:extLst>
           </a:blip>
-          <a:srcRect l="851" t="2223" r="49575" b="23738"/>
+          <a:srcRect l="2246" r="49273" b="25961"/>
           <a:stretch>
             <a:fillRect/>
           </a:stretch>
         </p:blipFill>
         <p:spPr>
           <a:xfrm>
-            <a:off x="4572000" y="1878988"/>
-            <a:ext cx="4533102" cy="3808303"/>
+            <a:off x="7402" y="1902478"/>
+            <a:ext cx="4525701" cy="3887801"/>
           </a:xfrm>
           <a:prstGeom prst="rect">
             <a:avLst/>

</xml_diff>